<commit_message>
feat: redesign Antigravity demo as staged Pages workflow
</commit_message>
<xml_diff>
--- a/exports/knowledge_flow/mighty_skill_bridge_antigravity_user_guide_2026.pptx
+++ b/exports/knowledge_flow/mighty_skill_bridge_antigravity_user_guide_2026.pptx
@@ -2,24 +2,24 @@
 <file path=ppt/presentation.xml><?xml version="1.0" encoding="utf-8"?>
 <p:presentation xmlns:p="http://schemas.openxmlformats.org/presentationml/2006/main">
   <p:sldMasterIdLst>
-    <p:sldMasterId xmlns:r="http://schemas.openxmlformats.org/officeDocument/2006/relationships" id="2147483648" r:id="Ra305d667e47c45fd"/>
+    <p:sldMasterId xmlns:r="http://schemas.openxmlformats.org/officeDocument/2006/relationships" id="2147483648" r:id="R0f7e3b18c70d4744"/>
   </p:sldMasterIdLst>
   <p:notesMasterIdLst>
-    <p:notesMasterId xmlns:r="http://schemas.openxmlformats.org/officeDocument/2006/relationships" r:id="R712e1e468fc749e5"/>
+    <p:notesMasterId xmlns:r="http://schemas.openxmlformats.org/officeDocument/2006/relationships" r:id="R15663b34f6ed4975"/>
   </p:notesMasterIdLst>
   <p:sldIdLst>
-    <p:sldId xmlns:r="http://schemas.openxmlformats.org/officeDocument/2006/relationships" id="256" r:id="R64fda90721c3401b"/>
-    <p:sldId xmlns:r="http://schemas.openxmlformats.org/officeDocument/2006/relationships" id="257" r:id="Raee49bca2d47442e"/>
-    <p:sldId xmlns:r="http://schemas.openxmlformats.org/officeDocument/2006/relationships" id="258" r:id="Rc1cc10d40ae34370"/>
-    <p:sldId xmlns:r="http://schemas.openxmlformats.org/officeDocument/2006/relationships" id="259" r:id="Rc26b355c43794b95"/>
-    <p:sldId xmlns:r="http://schemas.openxmlformats.org/officeDocument/2006/relationships" id="260" r:id="R277c3dacce4b47a4"/>
-    <p:sldId xmlns:r="http://schemas.openxmlformats.org/officeDocument/2006/relationships" id="261" r:id="R6ebb2e8b484849df"/>
-    <p:sldId xmlns:r="http://schemas.openxmlformats.org/officeDocument/2006/relationships" id="262" r:id="R8fb015f4f55e42d3"/>
-    <p:sldId xmlns:r="http://schemas.openxmlformats.org/officeDocument/2006/relationships" id="263" r:id="Rfef99ff11b3f4159"/>
-    <p:sldId xmlns:r="http://schemas.openxmlformats.org/officeDocument/2006/relationships" id="264" r:id="Rca3e4fda4af64051"/>
-    <p:sldId xmlns:r="http://schemas.openxmlformats.org/officeDocument/2006/relationships" id="265" r:id="R058ac9d2356a413a"/>
-    <p:sldId xmlns:r="http://schemas.openxmlformats.org/officeDocument/2006/relationships" id="266" r:id="R63254dfb61674d0c"/>
-    <p:sldId xmlns:r="http://schemas.openxmlformats.org/officeDocument/2006/relationships" id="267" r:id="R934a66c119ba4874"/>
+    <p:sldId xmlns:r="http://schemas.openxmlformats.org/officeDocument/2006/relationships" id="256" r:id="R7ea1648ba2ff4635"/>
+    <p:sldId xmlns:r="http://schemas.openxmlformats.org/officeDocument/2006/relationships" id="257" r:id="Rf98ed0f37de04989"/>
+    <p:sldId xmlns:r="http://schemas.openxmlformats.org/officeDocument/2006/relationships" id="258" r:id="Rcfcd003879984804"/>
+    <p:sldId xmlns:r="http://schemas.openxmlformats.org/officeDocument/2006/relationships" id="259" r:id="R07f4a3f6e7514c82"/>
+    <p:sldId xmlns:r="http://schemas.openxmlformats.org/officeDocument/2006/relationships" id="260" r:id="R17205e5c4c244fa5"/>
+    <p:sldId xmlns:r="http://schemas.openxmlformats.org/officeDocument/2006/relationships" id="261" r:id="R286916be97a04d8e"/>
+    <p:sldId xmlns:r="http://schemas.openxmlformats.org/officeDocument/2006/relationships" id="262" r:id="R99ed07b991c947da"/>
+    <p:sldId xmlns:r="http://schemas.openxmlformats.org/officeDocument/2006/relationships" id="263" r:id="Rca0623b2488d4242"/>
+    <p:sldId xmlns:r="http://schemas.openxmlformats.org/officeDocument/2006/relationships" id="264" r:id="R87aa6c31083c4f5e"/>
+    <p:sldId xmlns:r="http://schemas.openxmlformats.org/officeDocument/2006/relationships" id="265" r:id="R05fa5f6414f54b38"/>
+    <p:sldId xmlns:r="http://schemas.openxmlformats.org/officeDocument/2006/relationships" id="266" r:id="R9c920a07eb8e407f"/>
+    <p:sldId xmlns:r="http://schemas.openxmlformats.org/officeDocument/2006/relationships" id="267" r:id="R3b6bf28d74b54ed1"/>
   </p:sldIdLst>
   <p:sldSz cx="12191695" cy="6858000"/>
   <p:notesSz cx="6858000" cy="9144000"/>
@@ -476,7 +476,7 @@
           <a:lstStyle xmlns:a="http://schemas.openxmlformats.org/drawingml/2006/main"/>
           <a:p xmlns:a="http://schemas.openxmlformats.org/drawingml/2006/main">
             <a:r>
-              <a:t>冒頭は機能説明をせず、15分で成果と検証まで見せる資料であることだけを伝える。</a:t>
+              <a:t>Opening: one site changes visibly across three prompts.</a:t>
             </a:r>
           </a:p>
           <a:p xmlns:a="http://schemas.openxmlformats.org/drawingml/2006/main">
@@ -491,17 +491,7 @@
           </a:p>
           <a:p xmlns:a="http://schemas.openxmlformats.org/drawingml/2006/main">
             <a:r>
-              <a:t>- https://developers.googleblog.com/en/build-with-google-antigravity-our-new-agentic-development-platform/</a:t>
-            </a:r>
-          </a:p>
-          <a:p xmlns:a="http://schemas.openxmlformats.org/drawingml/2006/main">
-            <a:r>
-              <a:t>- https://mighty-link.com/</a:t>
-            </a:r>
-          </a:p>
-          <a:p xmlns:a="http://schemas.openxmlformats.org/drawingml/2006/main">
-            <a:r>
-              <a:t>[/Sources]</a:t>
+              <a:t>- Google Developers Blog: https://developers.googleblog.com/en/build-with-google-antigravity-our-new-agentic-development-platform/</a:t>
             </a:r>
           </a:p>
         </p:txBody>
@@ -571,7 +561,7 @@
           <a:lstStyle xmlns:a="http://schemas.openxmlformats.org/drawingml/2006/main"/>
           <a:p xmlns:a="http://schemas.openxmlformats.org/drawingml/2006/main">
             <a:r>
-              <a:t>90秒は観客が待たされていると感じる前に切り替えるための運用基準。原因調査は研修後に行う。</a:t>
+              <a:t>Switch after 90 seconds; do not debug production or change repositories.</a:t>
             </a:r>
           </a:p>
           <a:p xmlns:a="http://schemas.openxmlformats.org/drawingml/2006/main">
@@ -586,12 +576,12 @@
           </a:p>
           <a:p xmlns:a="http://schemas.openxmlformats.org/drawingml/2006/main">
             <a:r>
-              <a:t>- docs/demo/antigravity_workshop/README.md</a:t>
-            </a:r>
-          </a:p>
-          <a:p xmlns:a="http://schemas.openxmlformats.org/drawingml/2006/main">
-            <a:r>
-              <a:t>[/Sources]</a:t>
+              <a:t>- https://docs.github.com/en/actions/how-tos/deploy/configure-and-manage-deployments/view-deployment-history</a:t>
+            </a:r>
+          </a:p>
+          <a:p xmlns:a="http://schemas.openxmlformats.org/drawingml/2006/main">
+            <a:r>
+              <a:t>- https://github.com/kanta13jp1/mighty-link-antigravity-live-demo</a:t>
             </a:r>
           </a:p>
         </p:txBody>
@@ -661,7 +651,7 @@
           <a:lstStyle xmlns:a="http://schemas.openxmlformats.org/drawingml/2006/main"/>
           <a:p xmlns:a="http://schemas.openxmlformats.org/drawingml/2006/main">
             <a:r>
-              <a:t>主デモが止まった場合だけ使用する。どちらも合成データの読取りのみで、書込み承認を不要にする。</a:t>
+              <a:t>Both backups are read-only and preserve the learning objective.</a:t>
             </a:r>
           </a:p>
           <a:p xmlns:a="http://schemas.openxmlformats.org/drawingml/2006/main">
@@ -676,17 +666,7 @@
           </a:p>
           <a:p xmlns:a="http://schemas.openxmlformats.org/drawingml/2006/main">
             <a:r>
-              <a:t>- docs/demo/antigravity_workshop/BACKUP_PROMPTS.txt</a:t>
-            </a:r>
-          </a:p>
-          <a:p xmlns:a="http://schemas.openxmlformats.org/drawingml/2006/main">
-            <a:r>
-              <a:t>- https://antigravity.google/docs/</a:t>
-            </a:r>
-          </a:p>
-          <a:p xmlns:a="http://schemas.openxmlformats.org/drawingml/2006/main">
-            <a:r>
-              <a:t>[/Sources]</a:t>
+              <a:t>- Internal fallback: docs/demo/antigravity_workshop/BACKUP_PROMPTS.txt</a:t>
             </a:r>
           </a:p>
         </p:txBody>
@@ -756,7 +736,7 @@
           <a:lstStyle xmlns:a="http://schemas.openxmlformats.org/drawingml/2006/main"/>
           <a:p xmlns:a="http://schemas.openxmlformats.org/drawingml/2006/main">
             <a:r>
-              <a:t>締めはツールの機能ではなく、翌日から試す小さな業務を一人一つ決めること。共有時はプロンプトだけでなく確認方法も添える。</a:t>
+              <a:t>Close with a repeatable pattern: build, improve, verify, share.</a:t>
             </a:r>
           </a:p>
           <a:p xmlns:a="http://schemas.openxmlformats.org/drawingml/2006/main">
@@ -771,12 +751,7 @@
           </a:p>
           <a:p xmlns:a="http://schemas.openxmlformats.org/drawingml/2006/main">
             <a:r>
-              <a:t>- docs/demo/antigravity_workshop/README.md</a:t>
-            </a:r>
-          </a:p>
-          <a:p xmlns:a="http://schemas.openxmlformats.org/drawingml/2006/main">
-            <a:r>
-              <a:t>[/Sources]</a:t>
+              <a:t>- Internal workshop plan: docs/training/ANTIGRAVITY_USER_MANUAL.md</a:t>
             </a:r>
           </a:p>
         </p:txBody>
@@ -846,7 +821,7 @@
           <a:lstStyle xmlns:a="http://schemas.openxmlformats.org/drawingml/2006/main"/>
           <a:p xmlns:a="http://schemas.openxmlformats.org/drawingml/2006/main">
             <a:r>
-              <a:t>承認事項は、8/26の中心をこの一本のライブデモに置くこと。個人属性を根拠にせず、経営判断に必要な時間・安全・復旧性で確認する。</a:t>
+              <a:t>Confirm the three transformations, not a feature inventory.</a:t>
             </a:r>
           </a:p>
           <a:p xmlns:a="http://schemas.openxmlformats.org/drawingml/2006/main">
@@ -861,12 +836,7 @@
           </a:p>
           <a:p xmlns:a="http://schemas.openxmlformats.org/drawingml/2006/main">
             <a:r>
-              <a:t>- docs/demo/antigravity_workshop/README.md</a:t>
-            </a:r>
-          </a:p>
-          <a:p xmlns:a="http://schemas.openxmlformats.org/drawingml/2006/main">
-            <a:r>
-              <a:t>[/Sources]</a:t>
+              <a:t>- Internal demo design: docs/demo/antigravity_workshop/README.md</a:t>
             </a:r>
           </a:p>
         </p:txBody>
@@ -936,7 +906,7 @@
           <a:lstStyle xmlns:a="http://schemas.openxmlformats.org/drawingml/2006/main"/>
           <a:p xmlns:a="http://schemas.openxmlformats.org/drawingml/2006/main">
             <a:r>
-              <a:t>時間超過を防ぐため、機能紹介や設定変更はこの15分に入れない。各時刻で観客に見せる対象を一つに限定する。</a:t>
+              <a:t>Keep the 15-minute clock visible. Stop after the public URL check.</a:t>
             </a:r>
           </a:p>
           <a:p xmlns:a="http://schemas.openxmlformats.org/drawingml/2006/main">
@@ -951,12 +921,12 @@
           </a:p>
           <a:p xmlns:a="http://schemas.openxmlformats.org/drawingml/2006/main">
             <a:r>
-              <a:t>- docs/demo/antigravity_workshop/README.md</a:t>
-            </a:r>
-          </a:p>
-          <a:p xmlns:a="http://schemas.openxmlformats.org/drawingml/2006/main">
-            <a:r>
-              <a:t>[/Sources]</a:t>
+              <a:t>- https://antigravity.google/docs/artifacts</a:t>
+            </a:r>
+          </a:p>
+          <a:p xmlns:a="http://schemas.openxmlformats.org/drawingml/2006/main">
+            <a:r>
+              <a:t>- https://docs.github.com/en/pages/getting-started-with-github-pages/configuring-a-publishing-source-for-your-github-pages-site</a:t>
             </a:r>
           </a:p>
         </p:txBody>
@@ -1026,7 +996,7 @@
           <a:lstStyle xmlns:a="http://schemas.openxmlformats.org/drawingml/2006/main"/>
           <a:p xmlns:a="http://schemas.openxmlformats.org/drawingml/2006/main">
             <a:r>
-              <a:t>当日朝に検証コマンドを再実行する。ログインやインストールは投影中に行わない。</a:t>
+              <a:t>The dedicated Pages repository is a hard boundary from production.</a:t>
             </a:r>
           </a:p>
           <a:p xmlns:a="http://schemas.openxmlformats.org/drawingml/2006/main">
@@ -1041,22 +1011,12 @@
           </a:p>
           <a:p xmlns:a="http://schemas.openxmlformats.org/drawingml/2006/main">
             <a:r>
-              <a:t>- https://antigravity.google/docs/</a:t>
-            </a:r>
-          </a:p>
-          <a:p xmlns:a="http://schemas.openxmlformats.org/drawingml/2006/main">
-            <a:r>
-              <a:t>- https://antigravity.google/docs/ide/browser</a:t>
-            </a:r>
-          </a:p>
-          <a:p xmlns:a="http://schemas.openxmlformats.org/drawingml/2006/main">
-            <a:r>
-              <a:t>- docs/demo/antigravity_workshop/README.md</a:t>
-            </a:r>
-          </a:p>
-          <a:p xmlns:a="http://schemas.openxmlformats.org/drawingml/2006/main">
-            <a:r>
-              <a:t>[/Sources]</a:t>
+              <a:t>- https://docs.github.com/en/pages/getting-started-with-github-pages/configuring-a-publishing-source-for-your-github-pages-site</a:t>
+            </a:r>
+          </a:p>
+          <a:p xmlns:a="http://schemas.openxmlformats.org/drawingml/2006/main">
+            <a:r>
+              <a:t>- https://github.com/kanta13jp1/mighty-link-antigravity-live-demo</a:t>
             </a:r>
           </a:p>
         </p:txBody>
@@ -1126,7 +1086,7 @@
           <a:lstStyle xmlns:a="http://schemas.openxmlformats.org/drawingml/2006/main"/>
           <a:p xmlns:a="http://schemas.openxmlformats.org/drawingml/2006/main">
             <a:r>
-              <a:t>参加者に全部のUIを覚えさせない。進行状況、変更、証拠の三か所だけを指す。</a:t>
+              <a:t>Show Manager, Editor/Terminal, Browser, then the public URL.</a:t>
             </a:r>
           </a:p>
           <a:p xmlns:a="http://schemas.openxmlformats.org/drawingml/2006/main">
@@ -1141,12 +1101,12 @@
           </a:p>
           <a:p xmlns:a="http://schemas.openxmlformats.org/drawingml/2006/main">
             <a:r>
-              <a:t>- https://developers.googleblog.com/en/build-with-google-antigravity-our-new-agentic-development-platform/</a:t>
-            </a:r>
-          </a:p>
-          <a:p xmlns:a="http://schemas.openxmlformats.org/drawingml/2006/main">
-            <a:r>
-              <a:t>[/Sources]</a:t>
+              <a:t>- https://antigravity.google/docs/browser</a:t>
+            </a:r>
+          </a:p>
+          <a:p xmlns:a="http://schemas.openxmlformats.org/drawingml/2006/main">
+            <a:r>
+              <a:t>- https://antigravity.google/docs/artifacts</a:t>
             </a:r>
           </a:p>
         </p:txBody>
@@ -1216,7 +1176,7 @@
           <a:lstStyle xmlns:a="http://schemas.openxmlformats.org/drawingml/2006/main"/>
           <a:p xmlns:a="http://schemas.openxmlformats.org/drawingml/2006/main">
             <a:r>
-              <a:t>画面上の要約ではなくMAIN_PROMPT.txtをコピーする。送信前に出力先が専用フォルダであることを声に出して確認する。</a:t>
+              <a:t>Paste Prompt 1 without rewriting it on stage.</a:t>
             </a:r>
           </a:p>
           <a:p xmlns:a="http://schemas.openxmlformats.org/drawingml/2006/main">
@@ -1231,17 +1191,7 @@
           </a:p>
           <a:p xmlns:a="http://schemas.openxmlformats.org/drawingml/2006/main">
             <a:r>
-              <a:t>- docs/demo/antigravity_workshop/MAIN_PROMPT.txt</a:t>
-            </a:r>
-          </a:p>
-          <a:p xmlns:a="http://schemas.openxmlformats.org/drawingml/2006/main">
-            <a:r>
-              <a:t>- https://antigravity.google/docs/</a:t>
-            </a:r>
-          </a:p>
-          <a:p xmlns:a="http://schemas.openxmlformats.org/drawingml/2006/main">
-            <a:r>
-              <a:t>[/Sources]</a:t>
+              <a:t>- Internal prompt: docs/demo/antigravity_workshop/MAIN_PROMPT.txt</a:t>
             </a:r>
           </a:p>
         </p:txBody>
@@ -1311,7 +1261,7 @@
           <a:lstStyle xmlns:a="http://schemas.openxmlformats.org/drawingml/2006/main"/>
           <a:p xmlns:a="http://schemas.openxmlformats.org/drawingml/2006/main">
             <a:r>
-              <a:t>ツールログを読み上げず、4つの節目だけを短く実況する。承認カードが出たら対象を確認して一度だけ承認する。</a:t>
+              <a:t>Point to the filter counts and two selected sessions.</a:t>
             </a:r>
           </a:p>
           <a:p xmlns:a="http://schemas.openxmlformats.org/drawingml/2006/main">
@@ -1326,17 +1276,7 @@
           </a:p>
           <a:p xmlns:a="http://schemas.openxmlformats.org/drawingml/2006/main">
             <a:r>
-              <a:t>- https://antigravity.google/docs/subagents</a:t>
-            </a:r>
-          </a:p>
-          <a:p xmlns:a="http://schemas.openxmlformats.org/drawingml/2006/main">
-            <a:r>
-              <a:t>- https://antigravity.google/docs/cli/commands/agents</a:t>
-            </a:r>
-          </a:p>
-          <a:p xmlns:a="http://schemas.openxmlformats.org/drawingml/2006/main">
-            <a:r>
-              <a:t>[/Sources]</a:t>
+              <a:t>- Local browser evidence: exports/antigravity_demo_hypothesis_evidence/interaction_1440x900.png</a:t>
             </a:r>
           </a:p>
         </p:txBody>
@@ -1406,7 +1346,7 @@
           <a:lstStyle xmlns:a="http://schemas.openxmlformats.org/drawingml/2006/main"/>
           <a:p xmlns:a="http://schemas.openxmlformats.org/drawingml/2006/main">
             <a:r>
-              <a:t>Deny、Ask、Allowの優先順位を示す。デモは合成データと専用Projectに限定し、実データや認証情報は扱わない。</a:t>
+              <a:t>Pause at the approval question. Say 公開して only after reviewing remote and secret checks.</a:t>
             </a:r>
           </a:p>
           <a:p xmlns:a="http://schemas.openxmlformats.org/drawingml/2006/main">
@@ -1426,12 +1366,7 @@
           </a:p>
           <a:p xmlns:a="http://schemas.openxmlformats.org/drawingml/2006/main">
             <a:r>
-              <a:t>- https://antigravity.google/docs/ide/browser</a:t>
-            </a:r>
-          </a:p>
-          <a:p xmlns:a="http://schemas.openxmlformats.org/drawingml/2006/main">
-            <a:r>
-              <a:t>[/Sources]</a:t>
+              <a:t>- https://docs.github.com/en/pages/getting-started-with-github-pages/configuring-a-publishing-source-for-your-github-pages-site</a:t>
             </a:r>
           </a:p>
         </p:txBody>
@@ -1501,7 +1436,7 @@
           <a:lstStyle xmlns:a="http://schemas.openxmlformats.org/drawingml/2006/main"/>
           <a:p xmlns:a="http://schemas.openxmlformats.org/drawingml/2006/main">
             <a:r>
-              <a:t>成功条件を満たしたら追加機能を頼まない。デモ終了後に必要なら別タスクとして扱う。</a:t>
+              <a:t>End only when files, functions, and public HTTPS are all visible.</a:t>
             </a:r>
           </a:p>
           <a:p xmlns:a="http://schemas.openxmlformats.org/drawingml/2006/main">
@@ -1516,12 +1451,12 @@
           </a:p>
           <a:p xmlns:a="http://schemas.openxmlformats.org/drawingml/2006/main">
             <a:r>
-              <a:t>- docs/demo/antigravity_workshop/MAIN_PROMPT.txt</a:t>
-            </a:r>
-          </a:p>
-          <a:p xmlns:a="http://schemas.openxmlformats.org/drawingml/2006/main">
-            <a:r>
-              <a:t>[/Sources]</a:t>
+              <a:t>- https://docs.github.com/en/pages/getting-started-with-github-pages/configuring-a-publishing-source-for-your-github-pages-site</a:t>
+            </a:r>
+          </a:p>
+          <a:p xmlns:a="http://schemas.openxmlformats.org/drawingml/2006/main">
+            <a:r>
+              <a:t>- https://kanta13jp1.github.io/mighty-link-antigravity-live-demo/</a:t>
             </a:r>
           </a:p>
         </p:txBody>
@@ -4548,17 +4483,17 @@
   </p:cSld>
   <p:clrMap bg1="lt1" tx1="dk1" bg2="lt2" tx2="dk2" accent1="accent1" accent2="accent2" accent3="accent3" accent4="accent4" accent5="accent5" accent6="accent6" hlink="hlink" folHlink="folHlink"/>
   <p:sldLayoutIdLst>
-    <p:sldLayoutId xmlns:r="http://schemas.openxmlformats.org/officeDocument/2006/relationships" id="2147483649" r:id="R764fcc4daa9440ac"/>
-    <p:sldLayoutId xmlns:r="http://schemas.openxmlformats.org/officeDocument/2006/relationships" id="2147483650" r:id="R2e8b00b9dace4eb8"/>
-    <p:sldLayoutId xmlns:r="http://schemas.openxmlformats.org/officeDocument/2006/relationships" id="2147483651" r:id="R4318751530e0480f"/>
-    <p:sldLayoutId xmlns:r="http://schemas.openxmlformats.org/officeDocument/2006/relationships" id="2147483652" r:id="Rfa0a2c46d69640bf"/>
-    <p:sldLayoutId xmlns:r="http://schemas.openxmlformats.org/officeDocument/2006/relationships" id="2147483653" r:id="R62ac0c50a4ab46ec"/>
-    <p:sldLayoutId xmlns:r="http://schemas.openxmlformats.org/officeDocument/2006/relationships" id="2147483654" r:id="Re6c340f964c647d1"/>
-    <p:sldLayoutId xmlns:r="http://schemas.openxmlformats.org/officeDocument/2006/relationships" id="2147483655" r:id="R81b9599be8b14cce"/>
-    <p:sldLayoutId xmlns:r="http://schemas.openxmlformats.org/officeDocument/2006/relationships" id="2147483656" r:id="Rf9278a0595f847f7"/>
-    <p:sldLayoutId xmlns:r="http://schemas.openxmlformats.org/officeDocument/2006/relationships" id="2147483657" r:id="R5a315ea7a6a84bc4"/>
-    <p:sldLayoutId xmlns:r="http://schemas.openxmlformats.org/officeDocument/2006/relationships" id="2147483658" r:id="Rcc270d51a2284fa8"/>
-    <p:sldLayoutId xmlns:r="http://schemas.openxmlformats.org/officeDocument/2006/relationships" id="2147483659" r:id="R629c8d5d5d984182"/>
+    <p:sldLayoutId xmlns:r="http://schemas.openxmlformats.org/officeDocument/2006/relationships" id="2147483649" r:id="R0c52edecd07f4c5a"/>
+    <p:sldLayoutId xmlns:r="http://schemas.openxmlformats.org/officeDocument/2006/relationships" id="2147483650" r:id="R299b93cca89548f0"/>
+    <p:sldLayoutId xmlns:r="http://schemas.openxmlformats.org/officeDocument/2006/relationships" id="2147483651" r:id="Rad22155920244e50"/>
+    <p:sldLayoutId xmlns:r="http://schemas.openxmlformats.org/officeDocument/2006/relationships" id="2147483652" r:id="R28609813bfbe4296"/>
+    <p:sldLayoutId xmlns:r="http://schemas.openxmlformats.org/officeDocument/2006/relationships" id="2147483653" r:id="Re83334b0b97b48bc"/>
+    <p:sldLayoutId xmlns:r="http://schemas.openxmlformats.org/officeDocument/2006/relationships" id="2147483654" r:id="Rc3a32923989b4b85"/>
+    <p:sldLayoutId xmlns:r="http://schemas.openxmlformats.org/officeDocument/2006/relationships" id="2147483655" r:id="R0a6ea0a16ed54f13"/>
+    <p:sldLayoutId xmlns:r="http://schemas.openxmlformats.org/officeDocument/2006/relationships" id="2147483656" r:id="R0262491a2fa2481e"/>
+    <p:sldLayoutId xmlns:r="http://schemas.openxmlformats.org/officeDocument/2006/relationships" id="2147483657" r:id="Rcb5800968f70402e"/>
+    <p:sldLayoutId xmlns:r="http://schemas.openxmlformats.org/officeDocument/2006/relationships" id="2147483658" r:id="R4e3f1eb30cc24f7d"/>
+    <p:sldLayoutId xmlns:r="http://schemas.openxmlformats.org/officeDocument/2006/relationships" id="2147483659" r:id="R17fbf96bf3a14a7c"/>
   </p:sldLayoutIdLst>
   <p:txStyles>
     <p:titleStyle>
@@ -5417,7 +5352,7 @@
                 <a:ea typeface="Yu Gothic UI"/>
                 <a:cs typeface="Yu Gothic UI"/>
               </a:rPr>
-              <a:t>Google Antigravity</a:t>
+              <a:t>Webサイトを作る</a:t>
             </a:r>
           </a:p>
         </p:txBody>
@@ -5491,7 +5426,7 @@
                 <a:ea typeface="Yu Gothic UI"/>
                 <a:cs typeface="Yu Gothic UI"/>
               </a:rPr>
-              <a:t>ライブデモ</a:t>
+              <a:t>改善して、公開する</a:t>
             </a:r>
           </a:p>
         </p:txBody>
@@ -5553,7 +5488,7 @@
                 <a:ea typeface="Yu Gothic UI"/>
                 <a:cs typeface="Yu Gothic UI"/>
               </a:rPr>
-              <a:t>指示する。任せる。画面で確かめる。</a:t>
+              <a:t>3本のプロンプトで、変化を見せる。</a:t>
             </a:r>
           </a:p>
         </p:txBody>
@@ -5621,7 +5556,7 @@
                 <a:ea typeface="Yu Gothic UI"/>
                 <a:cs typeface="Yu Gothic UI"/>
               </a:rPr>
-              <a:t>社長事前確認版  |  15分デモ設計</a:t>
+              <a:t>社長事前確認版  |  15分ライブデモ</a:t>
             </a:r>
           </a:p>
         </p:txBody>
@@ -5892,7 +5827,7 @@
           <p:nvPr/>
         </p:nvPicPr>
         <p:blipFill>
-          <a:blip xmlns:r="http://schemas.openxmlformats.org/officeDocument/2006/relationships" xmlns:a="http://schemas.openxmlformats.org/drawingml/2006/main" r:embed="Rdc2f00087add477f"/>
+          <a:blip xmlns:r="http://schemas.openxmlformats.org/officeDocument/2006/relationships" xmlns:a="http://schemas.openxmlformats.org/drawingml/2006/main" r:embed="R67cf67fcfd1d4979"/>
           <a:stretch xmlns:a="http://schemas.openxmlformats.org/drawingml/2006/main">
             <a:fillRect l="0" t="0" r="0" b="0"/>
           </a:stretch>
@@ -5916,7 +5851,7 @@
           <p:nvPr/>
         </p:nvPicPr>
         <p:blipFill>
-          <a:blip xmlns:r="http://schemas.openxmlformats.org/officeDocument/2006/relationships" xmlns:a="http://schemas.openxmlformats.org/drawingml/2006/main" r:embed="R5aa8b9e086884050"/>
+          <a:blip xmlns:r="http://schemas.openxmlformats.org/officeDocument/2006/relationships" xmlns:a="http://schemas.openxmlformats.org/drawingml/2006/main" r:embed="Rca8037c36c5d461e"/>
           <a:stretch xmlns:a="http://schemas.openxmlformats.org/drawingml/2006/main"/>
         </p:blipFill>
         <p:spPr>
@@ -6244,7 +6179,7 @@
                 <a:ea typeface="Yu Gothic UI"/>
                 <a:cs typeface="Yu Gothic UI"/>
               </a:rPr>
-              <a:t>失敗しても、90秒で次へ進みます</a:t>
+              <a:t>失敗しても、90秒で見せ方を切り替えます</a:t>
             </a:r>
           </a:p>
         </p:txBody>
@@ -6614,7 +6549,7 @@
                 <a:ea typeface="Yu Gothic UI"/>
                 <a:cs typeface="Yu Gothic UI"/>
               </a:rPr>
-              <a:t>進展が見えない</a:t>
+              <a:t>生成が止まる</a:t>
             </a:r>
           </a:p>
           <a:p xmlns:a="http://schemas.openxmlformats.org/drawingml/2006/main">
@@ -6641,7 +6576,7 @@
                 <a:ea typeface="Yu Gothic UI"/>
                 <a:cs typeface="Yu Gothic UI"/>
               </a:rPr>
-              <a:t>→ 現在地を1回だけ尋ねる</a:t>
+              <a:t>→ ローカル完成版を開く</a:t>
             </a:r>
           </a:p>
           <a:p xmlns:a="http://schemas.openxmlformats.org/drawingml/2006/main">
@@ -6684,7 +6619,7 @@
                 <a:ea typeface="Yu Gothic UI"/>
                 <a:cs typeface="Yu Gothic UI"/>
               </a:rPr>
-              <a:t>ブラウザが止まる</a:t>
+              <a:t>Pages待機が長い</a:t>
             </a:r>
           </a:p>
           <a:p xmlns:a="http://schemas.openxmlformats.org/drawingml/2006/main">
@@ -6711,7 +6646,7 @@
                 <a:ea typeface="Yu Gothic UI"/>
                 <a:cs typeface="Yu Gothic UI"/>
               </a:rPr>
-              <a:t>→ output/index.htmlを手動で開く</a:t>
+              <a:t>→ 準備中URL + Actions green</a:t>
             </a:r>
           </a:p>
           <a:p xmlns:a="http://schemas.openxmlformats.org/drawingml/2006/main">
@@ -6754,7 +6689,7 @@
                 <a:ea typeface="Yu Gothic UI"/>
                 <a:cs typeface="Yu Gothic UI"/>
               </a:rPr>
-              <a:t>エラーが続く</a:t>
+              <a:t>remote不一致</a:t>
             </a:r>
           </a:p>
           <a:p xmlns:a="http://schemas.openxmlformats.org/drawingml/2006/main">
@@ -6781,7 +6716,7 @@
                 <a:ea typeface="Yu Gothic UI"/>
                 <a:cs typeface="Yu Gothic UI"/>
               </a:rPr>
-              <a:t>→ 読み取り専用の予備デモへ</a:t>
+              <a:t>→ pushせず公開手順を説明</a:t>
             </a:r>
           </a:p>
         </p:txBody>
@@ -6974,7 +6909,7 @@
                 <a:ea typeface="Yu Gothic UI"/>
                 <a:cs typeface="Yu Gothic UI"/>
               </a:rPr>
-              <a:t>×  再インストール</a:t>
+              <a:t>×  本番リポジトリへ切替</a:t>
             </a:r>
           </a:p>
           <a:p xmlns:a="http://schemas.openxmlformats.org/drawingml/2006/main">
@@ -7017,7 +6952,7 @@
                 <a:ea typeface="Yu Gothic UI"/>
                 <a:cs typeface="Yu Gothic UI"/>
               </a:rPr>
-              <a:t>×  モデルを何度も変更</a:t>
+              <a:t>×  secret確認を省略</a:t>
             </a:r>
           </a:p>
           <a:p xmlns:a="http://schemas.openxmlformats.org/drawingml/2006/main">
@@ -7060,7 +6995,7 @@
                 <a:ea typeface="Yu Gothic UI"/>
                 <a:cs typeface="Yu Gothic UI"/>
               </a:rPr>
-              <a:t>×  投影したまま長時間デバッグ</a:t>
+              <a:t>×  承認前にpush</a:t>
             </a:r>
           </a:p>
           <a:p xmlns:a="http://schemas.openxmlformats.org/drawingml/2006/main">
@@ -7103,7 +7038,7 @@
                 <a:ea typeface="Yu Gothic UI"/>
                 <a:cs typeface="Yu Gothic UI"/>
               </a:rPr>
-              <a:t>×  本番データや別Projectへ切替</a:t>
+              <a:t>×  投影したまま長時間デバッグ</a:t>
             </a:r>
           </a:p>
         </p:txBody>
@@ -7421,7 +7356,7 @@
                 <a:ea typeface="Yu Gothic UI"/>
                 <a:cs typeface="Yu Gothic UI"/>
               </a:rPr>
-              <a:t>予備デモは読み取り専用の2本です</a:t>
+              <a:t>予備デモも同じ3段階を説明できます</a:t>
             </a:r>
           </a:p>
         </p:txBody>
@@ -7680,7 +7615,7 @@
                 <a:ea typeface="Yu Gothic UI"/>
                 <a:cs typeface="Yu Gothic UI"/>
               </a:rPr>
-              <a:t>各3分  |  ファイル変更なし</a:t>
+              <a:t>各3分  |  ファイル変更・pushなし</a:t>
             </a:r>
           </a:p>
         </p:txBody>
@@ -7811,7 +7746,7 @@
                 <a:ea typeface="Yu Gothic UI"/>
                 <a:cs typeface="Yu Gothic UI"/>
               </a:rPr>
-              <a:t>経費CSV</a:t>
+              <a:t>完成版を操作</a:t>
             </a:r>
           </a:p>
         </p:txBody>
@@ -7924,7 +7859,7 @@
                 <a:ea typeface="Yu Gothic UI"/>
                 <a:cs typeface="Yu Gothic UI"/>
               </a:rPr>
-              <a:t>@.../input/expenses.csv から、10,000円超と</a:t>
+              <a:t>5カテゴリを切り替え、2件を参加候補へ。</a:t>
             </a:r>
           </a:p>
           <a:p xmlns:a="http://schemas.openxmlformats.org/drawingml/2006/main">
@@ -7951,7 +7886,7 @@
                 <a:ea typeface="Yu Gothic UI"/>
                 <a:cs typeface="Yu Gothic UI"/>
               </a:rPr>
-              <a:t>「同日・同額」を抽出し、Markdown表で回答。</a:t>
+              <a:t>ローカル画面だけで機能とデザインを確認。</a:t>
             </a:r>
           </a:p>
         </p:txBody>
@@ -8031,7 +7966,7 @@
                 <a:ea typeface="Yu Gothic UI"/>
                 <a:cs typeface="Yu Gothic UI"/>
               </a:rPr>
-              <a:t>WBS</a:t>
+              <a:t>3プロンプトを比較</a:t>
             </a:r>
           </a:p>
         </p:txBody>
@@ -8144,7 +8079,7 @@
                 <a:ea typeface="Yu Gothic UI"/>
                 <a:cs typeface="Yu Gothic UI"/>
               </a:rPr>
-              <a:t>@.../input/sample_wbs.tsv から、期限超過と今週期限を分け、</a:t>
+              <a:t>AIに任せること／人が確認すること／停止条件を</a:t>
             </a:r>
           </a:p>
           <a:p xmlns:a="http://schemas.openxmlformats.org/drawingml/2006/main">
@@ -8171,7 +8106,7 @@
                 <a:ea typeface="Yu Gothic UI"/>
                 <a:cs typeface="Yu Gothic UI"/>
               </a:rPr>
-              <a:t>優先3件を理由付きで回答。</a:t>
+              <a:t>3列で整理し、公開判断の違いを説明。</a:t>
             </a:r>
           </a:p>
         </p:txBody>
@@ -8259,7 +8194,7 @@
           <p:nvPr/>
         </p:nvPicPr>
         <p:blipFill>
-          <a:blip xmlns:r="http://schemas.openxmlformats.org/officeDocument/2006/relationships" xmlns:a="http://schemas.openxmlformats.org/drawingml/2006/main" r:embed="Rb71544733ff24a0e"/>
+          <a:blip xmlns:r="http://schemas.openxmlformats.org/officeDocument/2006/relationships" xmlns:a="http://schemas.openxmlformats.org/drawingml/2006/main" r:embed="R6592bf95333743c5"/>
           <a:stretch xmlns:a="http://schemas.openxmlformats.org/drawingml/2006/main">
             <a:fillRect l="0" t="0" r="0" b="0"/>
           </a:stretch>
@@ -8587,7 +8522,7 @@
                 <a:ea typeface="Yu Gothic UI"/>
                 <a:cs typeface="Yu Gothic UI"/>
               </a:rPr>
-              <a:t>8/27から、1人1業務1プロンプト</a:t>
+              <a:t>8/27から、1業務を3プロンプトで育てる</a:t>
             </a:r>
           </a:p>
         </p:txBody>
@@ -8959,7 +8894,7 @@
                 <a:ea typeface="Yu Gothic UI"/>
                 <a:cs typeface="Yu Gothic UI"/>
               </a:rPr>
-              <a:t>01  繰り返し業務を一つ選ぶ</a:t>
+              <a:t>01  小さく作る</a:t>
             </a:r>
           </a:p>
           <a:p xmlns:a="http://schemas.openxmlformats.org/drawingml/2006/main">
@@ -9002,7 +8937,7 @@
                 <a:ea typeface="Yu Gothic UI"/>
                 <a:cs typeface="Yu Gothic UI"/>
               </a:rPr>
-              <a:t>02  合成・匿名化データで試す</a:t>
+              <a:t>02  具体的に改善する</a:t>
             </a:r>
           </a:p>
           <a:p xmlns:a="http://schemas.openxmlformats.org/drawingml/2006/main">
@@ -9045,7 +8980,7 @@
                 <a:ea typeface="Yu Gothic UI"/>
                 <a:cs typeface="Yu Gothic UI"/>
               </a:rPr>
-              <a:t>03  役立ったプロンプトと確認方法を共有する</a:t>
+              <a:t>03  人が確認して共有する</a:t>
             </a:r>
           </a:p>
         </p:txBody>
@@ -9236,7 +9171,7 @@
                 <a:ea typeface="Yu Gothic UI"/>
                 <a:cs typeface="Yu Gothic UI"/>
               </a:rPr>
-              <a:t>1  prompt</a:t>
+              <a:t>1  task</a:t>
             </a:r>
           </a:p>
           <a:p xmlns:a="http://schemas.openxmlformats.org/drawingml/2006/main">
@@ -9263,7 +9198,7 @@
                 <a:ea typeface="Yu Gothic UI"/>
                 <a:cs typeface="Yu Gothic UI"/>
               </a:rPr>
-              <a:t>1  deliverable</a:t>
+              <a:t>3  prompts</a:t>
             </a:r>
           </a:p>
           <a:p xmlns:a="http://schemas.openxmlformats.org/drawingml/2006/main">
@@ -9290,7 +9225,7 @@
                 <a:ea typeface="Yu Gothic UI"/>
                 <a:cs typeface="Yu Gothic UI"/>
               </a:rPr>
-              <a:t>1  proof</a:t>
+              <a:t>1  public proof</a:t>
             </a:r>
           </a:p>
           <a:p xmlns:a="http://schemas.openxmlformats.org/drawingml/2006/main">
@@ -9360,7 +9295,7 @@
                 <a:ea typeface="Yu Gothic UI"/>
                 <a:cs typeface="Yu Gothic UI"/>
               </a:rPr>
-              <a:t>人が確かめる場所を</a:t>
+              <a:t>人が止める場所を</a:t>
             </a:r>
           </a:p>
           <a:p xmlns:a="http://schemas.openxmlformats.org/drawingml/2006/main">
@@ -9705,7 +9640,7 @@
                 <a:ea typeface="Yu Gothic UI"/>
                 <a:cs typeface="Yu Gothic UI"/>
               </a:rPr>
-              <a:t>この資料でご確認いただきたいのは3点です</a:t>
+              <a:t>この資料で確認するのは3つの変化です</a:t>
             </a:r>
           </a:p>
         </p:txBody>
@@ -9964,7 +9899,7 @@
                 <a:ea typeface="Yu Gothic UI"/>
                 <a:cs typeface="Yu Gothic UI"/>
               </a:rPr>
-              <a:t>01  短い</a:t>
+              <a:t>01  作る</a:t>
             </a:r>
           </a:p>
         </p:txBody>
@@ -10132,7 +10067,7 @@
                 <a:ea typeface="Yu Gothic UI"/>
                 <a:cs typeface="Yu Gothic UI"/>
               </a:rPr>
-              <a:t>15分</a:t>
+              <a:t>Prompt 1</a:t>
             </a:r>
           </a:p>
           <a:p xmlns:a="http://schemas.openxmlformats.org/drawingml/2006/main">
@@ -10175,7 +10110,7 @@
                 <a:ea typeface="Yu Gothic UI"/>
                 <a:cs typeface="Yu Gothic UI"/>
               </a:rPr>
-              <a:t>一つの流れだけを見せる</a:t>
+              <a:t>HTML / CSS</a:t>
             </a:r>
           </a:p>
           <a:p xmlns:a="http://schemas.openxmlformats.org/drawingml/2006/main">
@@ -10218,7 +10153,7 @@
                 <a:ea typeface="Yu Gothic UI"/>
                 <a:cs typeface="Yu Gothic UI"/>
               </a:rPr>
-              <a:t>指示 → 実行 → 確認</a:t>
+              <a:t>ローカルで確認</a:t>
             </a:r>
           </a:p>
         </p:txBody>
@@ -10298,7 +10233,7 @@
                 <a:ea typeface="Yu Gothic UI"/>
                 <a:cs typeface="Yu Gothic UI"/>
               </a:rPr>
-              <a:t>02  安全</a:t>
+              <a:t>02  育てる</a:t>
             </a:r>
           </a:p>
         </p:txBody>
@@ -10466,7 +10401,7 @@
                 <a:ea typeface="Yu Gothic UI"/>
                 <a:cs typeface="Yu Gothic UI"/>
               </a:rPr>
-              <a:t>合成データ</a:t>
+              <a:t>Prompt 2</a:t>
             </a:r>
           </a:p>
           <a:p xmlns:a="http://schemas.openxmlformats.org/drawingml/2006/main">
@@ -10509,7 +10444,7 @@
                 <a:ea typeface="Yu Gothic UI"/>
                 <a:cs typeface="Yu Gothic UI"/>
               </a:rPr>
-              <a:t>専用フォルダだけに出力</a:t>
+              <a:t>絞り込み / 参加候補</a:t>
             </a:r>
           </a:p>
           <a:p xmlns:a="http://schemas.openxmlformats.org/drawingml/2006/main">
@@ -10552,7 +10487,7 @@
                 <a:ea typeface="Yu Gothic UI"/>
                 <a:cs typeface="Yu Gothic UI"/>
               </a:rPr>
-              <a:t>迷った操作は承認しない</a:t>
+              <a:t>デザイン変更</a:t>
             </a:r>
           </a:p>
         </p:txBody>
@@ -10632,7 +10567,7 @@
                 <a:ea typeface="Yu Gothic UI"/>
                 <a:cs typeface="Yu Gothic UI"/>
               </a:rPr>
-              <a:t>03  復帰</a:t>
+              <a:t>03  公開する</a:t>
             </a:r>
           </a:p>
         </p:txBody>
@@ -10800,7 +10735,7 @@
                 <a:ea typeface="Yu Gothic UI"/>
                 <a:cs typeface="Yu Gothic UI"/>
               </a:rPr>
-              <a:t>90秒ルール</a:t>
+              <a:t>Prompt 3</a:t>
             </a:r>
           </a:p>
           <a:p xmlns:a="http://schemas.openxmlformats.org/drawingml/2006/main">
@@ -10843,7 +10778,7 @@
                 <a:ea typeface="Yu Gothic UI"/>
                 <a:cs typeface="Yu Gothic UI"/>
               </a:rPr>
-              <a:t>進展がなければ予備へ</a:t>
+              <a:t>人が承認してpush</a:t>
             </a:r>
           </a:p>
           <a:p xmlns:a="http://schemas.openxmlformats.org/drawingml/2006/main">
@@ -10886,7 +10821,7 @@
                 <a:ea typeface="Yu Gothic UI"/>
                 <a:cs typeface="Yu Gothic UI"/>
               </a:rPr>
-              <a:t>会場でデバッグしない</a:t>
+              <a:t>公開URLで確認</a:t>
             </a:r>
           </a:p>
         </p:txBody>
@@ -11204,7 +11139,7 @@
                 <a:ea typeface="Yu Gothic UI"/>
                 <a:cs typeface="Yu Gothic UI"/>
               </a:rPr>
-              <a:t>15分で「指示 → 実行 → 確認」まで見せます</a:t>
+              <a:t>15分で「作る → 育てる → 公開」まで見せます</a:t>
             </a:r>
           </a:p>
         </p:txBody>
@@ -11576,7 +11511,7 @@
                 <a:ea typeface="Yu Gothic UI"/>
                 <a:cs typeface="Yu Gothic UI"/>
               </a:rPr>
-              <a:t>00–02  指示　主デモプロンプトを貼る</a:t>
+              <a:t>00–04  作る　初版サイトを生成・確認</a:t>
             </a:r>
           </a:p>
           <a:p xmlns:a="http://schemas.openxmlformats.org/drawingml/2006/main">
@@ -11619,7 +11554,7 @@
                 <a:ea typeface="Yu Gothic UI"/>
                 <a:cs typeface="Yu Gothic UI"/>
               </a:rPr>
-              <a:t>02–07  実行　計画・編集・承認を1回だけ見せる</a:t>
+              <a:t>04–09  育てる　機能とデザインを追加</a:t>
             </a:r>
           </a:p>
           <a:p xmlns:a="http://schemas.openxmlformats.org/drawingml/2006/main">
@@ -11662,7 +11597,7 @@
                 <a:ea typeface="Yu Gothic UI"/>
                 <a:cs typeface="Yu Gothic UI"/>
               </a:rPr>
-              <a:t>07–12  確認　ブラウザと成果物を確認する</a:t>
+              <a:t>09–13  公開　差分確認 → 人が承認 → push</a:t>
             </a:r>
           </a:p>
           <a:p xmlns:a="http://schemas.openxmlformats.org/drawingml/2006/main">
@@ -11705,7 +11640,7 @@
                 <a:ea typeface="Yu Gothic UI"/>
                 <a:cs typeface="Yu Gothic UI"/>
               </a:rPr>
-              <a:t>12–15  振返り　変更・確認・未解決を3行で共有</a:t>
+              <a:t>13–15  確認　公開URLと操作結果を共有</a:t>
             </a:r>
           </a:p>
         </p:txBody>
@@ -11783,7 +11718,7 @@
                 <a:ea typeface="Yu Gothic UI"/>
                 <a:cs typeface="Yu Gothic UI"/>
               </a:rPr>
-              <a:t>観客が見るもの</a:t>
+              <a:t>観客が見る変化</a:t>
             </a:r>
           </a:p>
         </p:txBody>
@@ -11896,7 +11831,7 @@
                 <a:ea typeface="Yu Gothic UI"/>
                 <a:cs typeface="Yu Gothic UI"/>
               </a:rPr>
-              <a:t>1  prompt</a:t>
+              <a:t>1  local site</a:t>
             </a:r>
           </a:p>
           <a:p xmlns:a="http://schemas.openxmlformats.org/drawingml/2006/main">
@@ -11923,7 +11858,7 @@
                 <a:ea typeface="Yu Gothic UI"/>
                 <a:cs typeface="Yu Gothic UI"/>
               </a:rPr>
-              <a:t>1  file</a:t>
+              <a:t>2  feature additions</a:t>
             </a:r>
           </a:p>
           <a:p xmlns:a="http://schemas.openxmlformats.org/drawingml/2006/main">
@@ -11950,7 +11885,7 @@
                 <a:ea typeface="Yu Gothic UI"/>
                 <a:cs typeface="Yu Gothic UI"/>
               </a:rPr>
-              <a:t>1  browser</a:t>
+              <a:t>3  public URL</a:t>
             </a:r>
           </a:p>
           <a:p xmlns:a="http://schemas.openxmlformats.org/drawingml/2006/main">
@@ -11977,7 +11912,7 @@
                 <a:ea typeface="Yu Gothic UI"/>
                 <a:cs typeface="Yu Gothic UI"/>
               </a:rPr>
-              <a:t>1  report</a:t>
+              <a:t/>
             </a:r>
           </a:p>
           <a:p xmlns:a="http://schemas.openxmlformats.org/drawingml/2006/main">
@@ -11993,7 +11928,7 @@
                 <a:ea typeface="Yu Gothic UI"/>
                 <a:cs typeface="Yu Gothic UI"/>
               </a:rPr>
-              <a:t/>
+              <a:t>AIの回答ではなく、</a:t>
             </a:r>
           </a:p>
           <a:p xmlns:a="http://schemas.openxmlformats.org/drawingml/2006/main">
@@ -12020,34 +11955,7 @@
                 <a:ea typeface="Yu Gothic UI"/>
                 <a:cs typeface="Yu Gothic UI"/>
               </a:rPr>
-              <a:t>成功は、AIの回答ではなく</a:t>
-            </a:r>
-          </a:p>
-          <a:p xmlns:a="http://schemas.openxmlformats.org/drawingml/2006/main">
-            <a:pPr algn="l">
-              <a:lnSpc>
-                <a:spcPct val="125000"/>
-              </a:lnSpc>
-              <a:buNone/>
-              <a:defRPr sz="2100" b="1">
-                <a:solidFill>
-                  <a:srgbClr val="FFFFFF"/>
-                </a:solidFill>
-                <a:latin typeface="Yu Gothic UI"/>
-                <a:ea typeface="Yu Gothic UI"/>
-                <a:cs typeface="Yu Gothic UI"/>
-              </a:defRPr>
-            </a:pPr>
-            <a:r>
-              <a:rPr sz="2100" b="1">
-                <a:solidFill>
-                  <a:srgbClr val="FFFFFF"/>
-                </a:solidFill>
-                <a:latin typeface="Yu Gothic UI"/>
-                <a:ea typeface="Yu Gothic UI"/>
-                <a:cs typeface="Yu Gothic UI"/>
-              </a:rPr>
-              <a:t>人が成果を確認できた状態。</a:t>
+              <a:t>画面とURLで確かめる。</a:t>
             </a:r>
           </a:p>
         </p:txBody>
@@ -12365,7 +12273,7 @@
                 <a:ea typeface="Yu Gothic UI"/>
                 <a:cs typeface="Yu Gothic UI"/>
               </a:rPr>
-              <a:t>前日までに5点を緑にします</a:t>
+              <a:t>前日までに6点を緑にします</a:t>
             </a:r>
           </a:p>
         </p:txBody>
@@ -12624,7 +12532,7 @@
                 <a:ea typeface="Yu Gothic UI"/>
                 <a:cs typeface="Yu Gothic UI"/>
               </a:rPr>
-              <a:t>デモ端末チェック</a:t>
+              <a:t>デモ端末・公開先</a:t>
             </a:r>
           </a:p>
         </p:txBody>
@@ -12737,7 +12645,7 @@
                 <a:ea typeface="Yu Gothic UI"/>
                 <a:cs typeface="Yu Gothic UI"/>
               </a:rPr>
-              <a:t>01  最新版を起動し、ログイン済み</a:t>
+              <a:t>01  Antigravityへログイン</a:t>
             </a:r>
           </a:p>
           <a:p xmlns:a="http://schemas.openxmlformats.org/drawingml/2006/main">
@@ -12791,7 +12699,7 @@
                 <a:ea typeface="Yu Gothic UI"/>
                 <a:cs typeface="Yu Gothic UI"/>
               </a:rPr>
-              <a:t>03  このリポジトリをProjectで開く</a:t>
+              <a:t>03  GitHub CLIはkanta13jp1</a:t>
             </a:r>
           </a:p>
           <a:p xmlns:a="http://schemas.openxmlformats.org/drawingml/2006/main">
@@ -12818,7 +12726,7 @@
                 <a:ea typeface="Yu Gothic UI"/>
                 <a:cs typeface="Yu Gothic UI"/>
               </a:rPr>
-              <a:t>04  合成データ3点がそろう</a:t>
+              <a:t>04  専用Pages repoをProjectで開く</a:t>
             </a:r>
           </a:p>
           <a:p xmlns:a="http://schemas.openxmlformats.org/drawingml/2006/main">
@@ -12845,7 +12753,7 @@
                 <a:ea typeface="Yu Gothic UI"/>
                 <a:cs typeface="Yu Gothic UI"/>
               </a:rPr>
-              <a:t>05  下の検証コマンドがPASS</a:t>
+              <a:t>05  Pages green / デモ検証PASS</a:t>
             </a:r>
           </a:p>
           <a:p xmlns:a="http://schemas.openxmlformats.org/drawingml/2006/main">
@@ -12968,7 +12876,7 @@
                 <a:ea typeface="Yu Gothic UI"/>
                 <a:cs typeface="Yu Gothic UI"/>
               </a:rPr>
-              <a:t>PROJECT / WORKTREE</a:t>
+              <a:t>DEDICATED PAGES REPO</a:t>
             </a:r>
           </a:p>
         </p:txBody>
@@ -12982,7 +12890,7 @@
           <p:nvPr/>
         </p:nvPicPr>
         <p:blipFill>
-          <a:blip xmlns:r="http://schemas.openxmlformats.org/officeDocument/2006/relationships" xmlns:a="http://schemas.openxmlformats.org/drawingml/2006/main" r:embed="R0f7a9107d36342ae"/>
+          <a:blip xmlns:r="http://schemas.openxmlformats.org/officeDocument/2006/relationships" xmlns:a="http://schemas.openxmlformats.org/drawingml/2006/main" r:embed="R9a520d27352c4912"/>
           <a:stretch xmlns:a="http://schemas.openxmlformats.org/drawingml/2006/main">
             <a:fillRect l="0" t="0" r="0" b="0"/>
           </a:stretch>
@@ -13006,7 +12914,7 @@
           <p:nvPr/>
         </p:nvPicPr>
         <p:blipFill>
-          <a:blip xmlns:r="http://schemas.openxmlformats.org/officeDocument/2006/relationships" xmlns:a="http://schemas.openxmlformats.org/drawingml/2006/main" r:embed="R72c4f892b5024128"/>
+          <a:blip xmlns:r="http://schemas.openxmlformats.org/officeDocument/2006/relationships" xmlns:a="http://schemas.openxmlformats.org/drawingml/2006/main" r:embed="Rdc62e1a4e15e4750"/>
           <a:stretch xmlns:a="http://schemas.openxmlformats.org/drawingml/2006/main"/>
         </p:blipFill>
         <p:spPr>
@@ -13334,7 +13242,7 @@
                 <a:ea typeface="Yu Gothic UI"/>
                 <a:cs typeface="Yu Gothic UI"/>
               </a:rPr>
-              <a:t>見る場所は3つだけです</a:t>
+              <a:t>見る場所は4つだけです</a:t>
             </a:r>
           </a:p>
         </p:txBody>
@@ -13704,7 +13612,7 @@
                 <a:ea typeface="Yu Gothic UI"/>
                 <a:cs typeface="Yu Gothic UI"/>
               </a:rPr>
-              <a:t>1  Manager</a:t>
+              <a:t>1  Manager　指示と進行</a:t>
             </a:r>
           </a:p>
           <a:p xmlns:a="http://schemas.openxmlformats.org/drawingml/2006/main">
@@ -13731,23 +13639,28 @@
                 <a:ea typeface="Yu Gothic UI"/>
                 <a:cs typeface="Yu Gothic UI"/>
               </a:rPr>
-              <a:t>　プロンプトと進行状況</a:t>
-            </a:r>
-          </a:p>
-          <a:p xmlns:a="http://schemas.openxmlformats.org/drawingml/2006/main">
-            <a:pPr algn="l">
-              <a:buNone/>
-            </a:pPr>
-            <a:r>
-              <a:rPr sz="1200" b="0">
-                <a:solidFill>
-                  <a:srgbClr val="334155"/>
-                </a:solidFill>
-                <a:latin typeface="Yu Gothic UI"/>
-                <a:ea typeface="Yu Gothic UI"/>
-                <a:cs typeface="Yu Gothic UI"/>
-              </a:rPr>
               <a:t/>
+            </a:r>
+          </a:p>
+          <a:p xmlns:a="http://schemas.openxmlformats.org/drawingml/2006/main">
+            <a:pPr algn="l">
+              <a:buNone/>
+              <a:defRPr sz="1950" b="1">
+                <a:solidFill>
+                  <a:srgbClr val="FFFFFF"/>
+                </a:solidFill>
+              </a:defRPr>
+            </a:pPr>
+            <a:r>
+              <a:rPr sz="1950" b="1">
+                <a:solidFill>
+                  <a:srgbClr val="FFFFFF"/>
+                </a:solidFill>
+                <a:latin typeface="Yu Gothic UI"/>
+                <a:ea typeface="Yu Gothic UI"/>
+                <a:cs typeface="Yu Gothic UI"/>
+              </a:rPr>
+              <a:t>2  Editor / Terminal　差分と実行</a:t>
             </a:r>
           </a:p>
           <a:p xmlns:a="http://schemas.openxmlformats.org/drawingml/2006/main">
@@ -13774,7 +13687,7 @@
                 <a:ea typeface="Yu Gothic UI"/>
                 <a:cs typeface="Yu Gothic UI"/>
               </a:rPr>
-              <a:t>2  Editor / Terminal</a:t>
+              <a:t/>
             </a:r>
           </a:p>
           <a:p xmlns:a="http://schemas.openxmlformats.org/drawingml/2006/main">
@@ -13801,7 +13714,7 @@
                 <a:ea typeface="Yu Gothic UI"/>
                 <a:cs typeface="Yu Gothic UI"/>
               </a:rPr>
-              <a:t>　変更ファイルと実行内容</a:t>
+              <a:t>3  Browser　ローカル確認</a:t>
             </a:r>
           </a:p>
           <a:p xmlns:a="http://schemas.openxmlformats.org/drawingml/2006/main">
@@ -13844,34 +13757,7 @@
                 <a:ea typeface="Yu Gothic UI"/>
                 <a:cs typeface="Yu Gothic UI"/>
               </a:rPr>
-              <a:t>3  Artifacts / Browser</a:t>
-            </a:r>
-          </a:p>
-          <a:p xmlns:a="http://schemas.openxmlformats.org/drawingml/2006/main">
-            <a:pPr algn="l">
-              <a:lnSpc>
-                <a:spcPct val="122000"/>
-              </a:lnSpc>
-              <a:buNone/>
-              <a:defRPr sz="1950" b="1">
-                <a:solidFill>
-                  <a:srgbClr val="FFFFFF"/>
-                </a:solidFill>
-                <a:latin typeface="Yu Gothic UI"/>
-                <a:ea typeface="Yu Gothic UI"/>
-                <a:cs typeface="Yu Gothic UI"/>
-              </a:defRPr>
-            </a:pPr>
-            <a:r>
-              <a:rPr sz="1950" b="1">
-                <a:solidFill>
-                  <a:srgbClr val="FFFFFF"/>
-                </a:solidFill>
-                <a:latin typeface="Yu Gothic UI"/>
-                <a:ea typeface="Yu Gothic UI"/>
-                <a:cs typeface="Yu Gothic UI"/>
-              </a:rPr>
-              <a:t>　成果と確認結果</a:t>
+              <a:t>4  GitHub Pages　公開URL</a:t>
             </a:r>
           </a:p>
         </p:txBody>
@@ -13951,7 +13837,7 @@
                 <a:ea typeface="Yu Gothic UI"/>
                 <a:cs typeface="Yu Gothic UI"/>
               </a:rPr>
-              <a:t>EDITOR + MANAGER</a:t>
+              <a:t>EDITOR + MANAGER + BROWSER</a:t>
             </a:r>
           </a:p>
         </p:txBody>
@@ -13965,7 +13851,7 @@
           <p:nvPr/>
         </p:nvPicPr>
         <p:blipFill>
-          <a:blip xmlns:r="http://schemas.openxmlformats.org/officeDocument/2006/relationships" xmlns:a="http://schemas.openxmlformats.org/drawingml/2006/main" r:embed="R1430bfaadcb24b0c"/>
+          <a:blip xmlns:r="http://schemas.openxmlformats.org/officeDocument/2006/relationships" xmlns:a="http://schemas.openxmlformats.org/drawingml/2006/main" r:embed="R41c439403b2243cb"/>
           <a:stretch xmlns:a="http://schemas.openxmlformats.org/drawingml/2006/main">
             <a:fillRect l="0" t="0" r="0" b="0"/>
           </a:stretch>
@@ -13989,7 +13875,7 @@
           <p:nvPr/>
         </p:nvPicPr>
         <p:blipFill>
-          <a:blip xmlns:r="http://schemas.openxmlformats.org/officeDocument/2006/relationships" xmlns:a="http://schemas.openxmlformats.org/drawingml/2006/main" r:embed="R8400028032504e0c"/>
+          <a:blip xmlns:r="http://schemas.openxmlformats.org/officeDocument/2006/relationships" xmlns:a="http://schemas.openxmlformats.org/drawingml/2006/main" r:embed="R66d299eb6d034023"/>
           <a:stretch xmlns:a="http://schemas.openxmlformats.org/drawingml/2006/main"/>
         </p:blipFill>
         <p:spPr>
@@ -14255,7 +14141,7 @@
                 <a:ea typeface="Yu Gothic UI"/>
                 <a:cs typeface="Yu Gothic UI"/>
               </a:rPr>
-              <a:t>MIGHTYLINK  |  8/26 社内AI研修  |  PRIMARY PROMPT</a:t>
+              <a:t>MIGHTYLINK  |  8/26 社内AI研修  |  PROMPT 1 / BUILD</a:t>
             </a:r>
           </a:p>
         </p:txBody>
@@ -14317,7 +14203,7 @@
                 <a:ea typeface="Yu Gothic UI"/>
                 <a:cs typeface="Yu Gothic UI"/>
               </a:rPr>
-              <a:t>この1本をコピーして開始します</a:t>
+              <a:t>Prompt 1　まずWebサイトを作ります</a:t>
             </a:r>
           </a:p>
         </p:txBody>
@@ -14574,7 +14460,7 @@
                 <a:ea typeface="Yu Gothic UI"/>
                 <a:cs typeface="Yu Gothic UI"/>
               </a:rPr>
-              <a:t>入力・出力・確認を一度に指定</a:t>
+              <a:t>入力・出力・禁止を明示</a:t>
             </a:r>
           </a:p>
         </p:txBody>
@@ -14771,7 +14657,7 @@
                 <a:ea typeface="Yu Gothic UI"/>
                 <a:cs typeface="Yu Gothic UI"/>
               </a:rPr>
-              <a:t>@docs/demo/antigravity_workshop/input/</a:t>
+              <a:t>@SITE_BRIEF.md を読み、</a:t>
             </a:r>
           </a:p>
           <a:p xmlns:a="http://schemas.openxmlformats.org/drawingml/2006/main">
@@ -14798,7 +14684,7 @@
                 <a:ea typeface="Yu Gothic UI"/>
                 <a:cs typeface="Yu Gothic UI"/>
               </a:rPr>
-              <a:t>customer_interview_memo.md を読み、</a:t>
+              <a:t>index.html と styles.css を作成。</a:t>
             </a:r>
           </a:p>
           <a:p xmlns:a="http://schemas.openxmlformats.org/drawingml/2006/main">
@@ -14825,7 +14711,7 @@
                 <a:ea typeface="Yu Gothic UI"/>
                 <a:cs typeface="Yu Gothic UI"/>
               </a:rPr>
-              <a:t>output/index.html を作成してください。</a:t>
+              <a:t/>
             </a:r>
           </a:p>
           <a:p xmlns:a="http://schemas.openxmlformats.org/drawingml/2006/main">
@@ -14833,7 +14719,7 @@
               <a:buNone/>
             </a:pPr>
             <a:r>
-              <a:t/>
+              <a:t>4セッションと合成データ表示、</a:t>
             </a:r>
           </a:p>
           <a:p xmlns:a="http://schemas.openxmlformats.org/drawingml/2006/main">
@@ -14860,7 +14746,7 @@
                 <a:ea typeface="Yu Gothic UI"/>
                 <a:cs typeface="Yu Gothic UI"/>
               </a:rPr>
-              <a:t>HTML/CSSだけで、顧客課題／提案／適合スコア／</a:t>
+              <a:t>assets/workshop-hero.png を使用。</a:t>
             </a:r>
           </a:p>
           <a:p xmlns:a="http://schemas.openxmlformats.org/drawingml/2006/main">
@@ -14887,7 +14773,7 @@
                 <a:ea typeface="Yu Gothic UI"/>
                 <a:cs typeface="Yu Gothic UI"/>
               </a:rPr>
-              <a:t>次アクションを1画面に表示。既存ファイルは変更せず、</a:t>
+              <a:t>この段階ではJavaScriptなし。</a:t>
             </a:r>
           </a:p>
           <a:p xmlns:a="http://schemas.openxmlformats.org/drawingml/2006/main">
@@ -14914,7 +14800,7 @@
                 <a:ea typeface="Yu Gothic UI"/>
                 <a:cs typeface="Yu Gothic UI"/>
               </a:rPr>
-              <a:t>ブラウザで4項目・文字切れ・モバイル幅を確認。</a:t>
+              <a:t>commit / push は実行しない。</a:t>
             </a:r>
           </a:p>
           <a:p xmlns:a="http://schemas.openxmlformats.org/drawingml/2006/main">
@@ -14941,7 +14827,34 @@
                 <a:ea typeface="Yu Gothic UI"/>
                 <a:cs typeface="Yu Gothic UI"/>
               </a:rPr>
-              <a:t>最後に変更／確認／未解決を3行で報告する。</a:t>
+              <a:t/>
+            </a:r>
+          </a:p>
+          <a:p xmlns:a="http://schemas.openxmlformats.org/drawingml/2006/main">
+            <a:pPr algn="l">
+              <a:lnSpc>
+                <a:spcPct val="110000"/>
+              </a:lnSpc>
+              <a:buNone/>
+              <a:defRPr sz="1875" b="0">
+                <a:solidFill>
+                  <a:srgbClr val="FFFFFF"/>
+                </a:solidFill>
+                <a:latin typeface="Yu Gothic UI"/>
+                <a:ea typeface="Yu Gothic UI"/>
+                <a:cs typeface="Yu Gothic UI"/>
+              </a:defRPr>
+            </a:pPr>
+            <a:r>
+              <a:rPr sz="1875" b="0">
+                <a:solidFill>
+                  <a:srgbClr val="FFFFFF"/>
+                </a:solidFill>
+                <a:latin typeface="Yu Gothic UI"/>
+                <a:ea typeface="Yu Gothic UI"/>
+                <a:cs typeface="Yu Gothic UI"/>
+              </a:rPr>
+              <a:t>1440x900 / 390x844で確認。</a:t>
             </a:r>
           </a:p>
         </p:txBody>
@@ -15121,7 +15034,7 @@
           <p:nvPr/>
         </p:nvPicPr>
         <p:blipFill>
-          <a:blip xmlns:r="http://schemas.openxmlformats.org/officeDocument/2006/relationships" xmlns:a="http://schemas.openxmlformats.org/drawingml/2006/main" r:embed="R0959a29e860e4fc4"/>
+          <a:blip xmlns:r="http://schemas.openxmlformats.org/officeDocument/2006/relationships" xmlns:a="http://schemas.openxmlformats.org/drawingml/2006/main" r:embed="R8f4c0def362d4eba"/>
           <a:stretch xmlns:a="http://schemas.openxmlformats.org/drawingml/2006/main">
             <a:fillRect l="0" t="0" r="0" b="0"/>
           </a:stretch>
@@ -15387,7 +15300,7 @@
                 <a:ea typeface="Yu Gothic UI"/>
                 <a:cs typeface="Yu Gothic UI"/>
               </a:rPr>
-              <a:t>MIGHTYLINK  |  8/26 社内AI研修  |  OBSERVE</a:t>
+              <a:t>MIGHTYLINK  |  8/26 社内AI研修  |  PROMPT 2 / IMPROVE</a:t>
             </a:r>
           </a:p>
         </p:txBody>
@@ -15449,7 +15362,7 @@
                 <a:ea typeface="Yu Gothic UI"/>
                 <a:cs typeface="Yu Gothic UI"/>
               </a:rPr>
-              <a:t>送信後は4場面だけを見せます</a:t>
+              <a:t>Prompt 2　機能とデザインを育てます</a:t>
             </a:r>
           </a:p>
         </p:txBody>
@@ -15708,7 +15621,7 @@
                 <a:ea typeface="Yu Gothic UI"/>
                 <a:cs typeface="Yu Gothic UI"/>
               </a:rPr>
-              <a:t>実況する順番</a:t>
+              <a:t>追加して確かめる</a:t>
             </a:r>
           </a:p>
         </p:txBody>
@@ -15803,9 +15716,9 @@
                 <a:spcPct val="120000"/>
               </a:lnSpc>
               <a:buNone/>
-              <a:defRPr sz="1950" b="0">
-                <a:solidFill>
-                  <a:srgbClr val="14212B"/>
+              <a:defRPr sz="1725" b="0">
+                <a:solidFill>
+                  <a:srgbClr val="17242B"/>
                 </a:solidFill>
                 <a:latin typeface="Yu Gothic UI"/>
                 <a:ea typeface="Yu Gothic UI"/>
@@ -15813,31 +15726,36 @@
               </a:defRPr>
             </a:pPr>
             <a:r>
-              <a:rPr sz="1950" b="0">
-                <a:solidFill>
-                  <a:srgbClr val="14212B"/>
-                </a:solidFill>
-                <a:latin typeface="Yu Gothic UI"/>
-                <a:ea typeface="Yu Gothic UI"/>
-                <a:cs typeface="Yu Gothic UI"/>
-              </a:rPr>
-              <a:t>01  Plan　出力先と禁止事項</a:t>
-            </a:r>
-          </a:p>
-          <a:p xmlns:a="http://schemas.openxmlformats.org/drawingml/2006/main">
-            <a:pPr algn="l">
-              <a:buNone/>
-            </a:pPr>
-            <a:r>
-              <a:rPr sz="1200" b="0">
-                <a:solidFill>
-                  <a:srgbClr val="334155"/>
-                </a:solidFill>
-                <a:latin typeface="Yu Gothic UI"/>
-                <a:ea typeface="Yu Gothic UI"/>
-                <a:cs typeface="Yu Gothic UI"/>
-              </a:rPr>
-              <a:t/>
+              <a:rPr sz="1725" b="0">
+                <a:solidFill>
+                  <a:srgbClr val="17242B"/>
+                </a:solidFill>
+                <a:latin typeface="Yu Gothic UI"/>
+                <a:ea typeface="Yu Gothic UI"/>
+                <a:cs typeface="Yu Gothic UI"/>
+              </a:rPr>
+              <a:t>01  Filter　5カテゴリ</a:t>
+            </a:r>
+          </a:p>
+          <a:p xmlns:a="http://schemas.openxmlformats.org/drawingml/2006/main">
+            <a:pPr algn="l">
+              <a:buNone/>
+              <a:defRPr sz="1725">
+                <a:solidFill>
+                  <a:srgbClr val="17242B"/>
+                </a:solidFill>
+              </a:defRPr>
+            </a:pPr>
+            <a:r>
+              <a:rPr sz="1725" b="0">
+                <a:solidFill>
+                  <a:srgbClr val="17242B"/>
+                </a:solidFill>
+                <a:latin typeface="Yu Gothic UI"/>
+                <a:ea typeface="Yu Gothic UI"/>
+                <a:cs typeface="Yu Gothic UI"/>
+              </a:rPr>
+              <a:t>02  Select　参加候補</a:t>
             </a:r>
           </a:p>
           <a:p xmlns:a="http://schemas.openxmlformats.org/drawingml/2006/main">
@@ -15846,9 +15764,9 @@
                 <a:spcPct val="120000"/>
               </a:lnSpc>
               <a:buNone/>
-              <a:defRPr sz="1950" b="0">
-                <a:solidFill>
-                  <a:srgbClr val="14212B"/>
+              <a:defRPr sz="1725" b="0">
+                <a:solidFill>
+                  <a:srgbClr val="17242B"/>
                 </a:solidFill>
                 <a:latin typeface="Yu Gothic UI"/>
                 <a:ea typeface="Yu Gothic UI"/>
@@ -15856,31 +15774,36 @@
               </a:defRPr>
             </a:pPr>
             <a:r>
-              <a:rPr sz="1950" b="0">
-                <a:solidFill>
-                  <a:srgbClr val="14212B"/>
-                </a:solidFill>
-                <a:latin typeface="Yu Gothic UI"/>
-                <a:ea typeface="Yu Gothic UI"/>
-                <a:cs typeface="Yu Gothic UI"/>
-              </a:rPr>
-              <a:t>02  Edit　index.htmlだけを変更</a:t>
-            </a:r>
-          </a:p>
-          <a:p xmlns:a="http://schemas.openxmlformats.org/drawingml/2006/main">
-            <a:pPr algn="l">
-              <a:buNone/>
-            </a:pPr>
-            <a:r>
-              <a:rPr sz="1200" b="0">
-                <a:solidFill>
-                  <a:srgbClr val="334155"/>
-                </a:solidFill>
-                <a:latin typeface="Yu Gothic UI"/>
-                <a:ea typeface="Yu Gothic UI"/>
-                <a:cs typeface="Yu Gothic UI"/>
-              </a:rPr>
-              <a:t/>
+              <a:rPr sz="1725" b="0">
+                <a:solidFill>
+                  <a:srgbClr val="17242B"/>
+                </a:solidFill>
+                <a:latin typeface="Yu Gothic UI"/>
+                <a:ea typeface="Yu Gothic UI"/>
+                <a:cs typeface="Yu Gothic UI"/>
+              </a:rPr>
+              <a:t>03  State　件数と名称</a:t>
+            </a:r>
+          </a:p>
+          <a:p xmlns:a="http://schemas.openxmlformats.org/drawingml/2006/main">
+            <a:pPr algn="l">
+              <a:buNone/>
+              <a:defRPr sz="1725">
+                <a:solidFill>
+                  <a:srgbClr val="17242B"/>
+                </a:solidFill>
+              </a:defRPr>
+            </a:pPr>
+            <a:r>
+              <a:rPr sz="1725" b="0">
+                <a:solidFill>
+                  <a:srgbClr val="17242B"/>
+                </a:solidFill>
+                <a:latin typeface="Yu Gothic UI"/>
+                <a:ea typeface="Yu Gothic UI"/>
+                <a:cs typeface="Yu Gothic UI"/>
+              </a:rPr>
+              <a:t>04  A11y　pressed / live</a:t>
             </a:r>
           </a:p>
           <a:p xmlns:a="http://schemas.openxmlformats.org/drawingml/2006/main">
@@ -15889,9 +15812,9 @@
                 <a:spcPct val="120000"/>
               </a:lnSpc>
               <a:buNone/>
-              <a:defRPr sz="1950" b="0">
-                <a:solidFill>
-                  <a:srgbClr val="14212B"/>
+              <a:defRPr sz="1725" b="0">
+                <a:solidFill>
+                  <a:srgbClr val="17242B"/>
                 </a:solidFill>
                 <a:latin typeface="Yu Gothic UI"/>
                 <a:ea typeface="Yu Gothic UI"/>
@@ -15899,58 +15822,36 @@
               </a:defRPr>
             </a:pPr>
             <a:r>
-              <a:rPr sz="1950" b="0">
-                <a:solidFill>
-                  <a:srgbClr val="14212B"/>
-                </a:solidFill>
-                <a:latin typeface="Yu Gothic UI"/>
-                <a:ea typeface="Yu Gothic UI"/>
-                <a:cs typeface="Yu Gothic UI"/>
-              </a:rPr>
-              <a:t>03  Browser　4項目と表示幅を確認</a:t>
-            </a:r>
-          </a:p>
-          <a:p xmlns:a="http://schemas.openxmlformats.org/drawingml/2006/main">
-            <a:pPr algn="l">
-              <a:buNone/>
-            </a:pPr>
-            <a:r>
-              <a:rPr sz="1200" b="0">
-                <a:solidFill>
-                  <a:srgbClr val="334155"/>
-                </a:solidFill>
-                <a:latin typeface="Yu Gothic UI"/>
-                <a:ea typeface="Yu Gothic UI"/>
-                <a:cs typeface="Yu Gothic UI"/>
-              </a:rPr>
-              <a:t/>
-            </a:r>
-          </a:p>
-          <a:p xmlns:a="http://schemas.openxmlformats.org/drawingml/2006/main">
-            <a:pPr algn="l">
-              <a:lnSpc>
-                <a:spcPct val="120000"/>
-              </a:lnSpc>
-              <a:buNone/>
-              <a:defRPr sz="1950" b="0">
-                <a:solidFill>
-                  <a:srgbClr val="14212B"/>
-                </a:solidFill>
-                <a:latin typeface="Yu Gothic UI"/>
-                <a:ea typeface="Yu Gothic UI"/>
-                <a:cs typeface="Yu Gothic UI"/>
+              <a:rPr sz="1725" b="0">
+                <a:solidFill>
+                  <a:srgbClr val="17242B"/>
+                </a:solidFill>
+                <a:latin typeface="Yu Gothic UI"/>
+                <a:ea typeface="Yu Gothic UI"/>
+                <a:cs typeface="Yu Gothic UI"/>
+              </a:rPr>
+              <a:t>05  Design　公式色 / 1列</a:t>
+            </a:r>
+          </a:p>
+          <a:p xmlns:a="http://schemas.openxmlformats.org/drawingml/2006/main">
+            <a:pPr algn="l">
+              <a:buNone/>
+              <a:defRPr sz="1725">
+                <a:solidFill>
+                  <a:srgbClr val="17242B"/>
+                </a:solidFill>
               </a:defRPr>
             </a:pPr>
             <a:r>
-              <a:rPr sz="1950" b="0">
-                <a:solidFill>
-                  <a:srgbClr val="14212B"/>
-                </a:solidFill>
-                <a:latin typeface="Yu Gothic UI"/>
-                <a:ea typeface="Yu Gothic UI"/>
-                <a:cs typeface="Yu Gothic UI"/>
-              </a:rPr>
-              <a:t>04  Report　変更／確認／未解決を3行</a:t>
+              <a:rPr sz="1725" b="0">
+                <a:solidFill>
+                  <a:srgbClr val="17242B"/>
+                </a:solidFill>
+                <a:latin typeface="Yu Gothic UI"/>
+                <a:ea typeface="Yu Gothic UI"/>
+                <a:cs typeface="Yu Gothic UI"/>
+              </a:rPr>
+              <a:t>06  Verify　4,1,1,1,1 / 2件</a:t>
             </a:r>
           </a:p>
         </p:txBody>
@@ -16030,7 +15931,7 @@
                 <a:ea typeface="Yu Gothic UI"/>
                 <a:cs typeface="Yu Gothic UI"/>
               </a:rPr>
-              <a:t>AGENTS</a:t>
+              <a:t>FUNCTION + DESIGN</a:t>
             </a:r>
           </a:p>
         </p:txBody>
@@ -16044,7 +15945,7 @@
           <p:nvPr/>
         </p:nvPicPr>
         <p:blipFill>
-          <a:blip xmlns:r="http://schemas.openxmlformats.org/officeDocument/2006/relationships" xmlns:a="http://schemas.openxmlformats.org/drawingml/2006/main" r:embed="Rc3f46b90e28f4c66"/>
+          <a:blip xmlns:r="http://schemas.openxmlformats.org/officeDocument/2006/relationships" xmlns:a="http://schemas.openxmlformats.org/drawingml/2006/main" r:embed="Rec8631fae47041d5"/>
           <a:stretch xmlns:a="http://schemas.openxmlformats.org/drawingml/2006/main">
             <a:fillRect l="0" t="0" r="0" b="0"/>
           </a:stretch>
@@ -16068,8 +15969,11 @@
           <p:nvPr/>
         </p:nvPicPr>
         <p:blipFill>
-          <a:blip xmlns:r="http://schemas.openxmlformats.org/officeDocument/2006/relationships" xmlns:a="http://schemas.openxmlformats.org/drawingml/2006/main" r:embed="R7ecf3dcc93174b55"/>
-          <a:stretch xmlns:a="http://schemas.openxmlformats.org/drawingml/2006/main"/>
+          <a:blip xmlns:r="http://schemas.openxmlformats.org/officeDocument/2006/relationships" xmlns:a="http://schemas.openxmlformats.org/drawingml/2006/main" r:embed="R2cc625da237b4b73"/>
+          <a:srcRect xmlns:a="http://schemas.openxmlformats.org/drawingml/2006/main" l="3255" t="0" r="3255" b="0"/>
+          <a:stretch xmlns:a="http://schemas.openxmlformats.org/drawingml/2006/main">
+            <a:fillRect l="0" t="0" r="0" b="0"/>
+          </a:stretch>
         </p:blipFill>
         <p:spPr>
           <a:xfrm xmlns:a="http://schemas.openxmlformats.org/drawingml/2006/main">
@@ -16077,9 +15981,7 @@
             <a:ext cx="4857750" cy="3247536"/>
           </a:xfrm>
           <a:prstGeom xmlns:a="http://schemas.openxmlformats.org/drawingml/2006/main" prst="roundRect">
-            <a:avLst>
-              <a:gd name="adj" fmla="val 1630"/>
-            </a:avLst>
+            <a:avLst/>
           </a:prstGeom>
         </p:spPr>
       </p:pic>
@@ -16334,7 +16236,7 @@
                 <a:ea typeface="Yu Gothic UI"/>
                 <a:cs typeface="Yu Gothic UI"/>
               </a:rPr>
-              <a:t>MIGHTYLINK  |  8/26 社内AI研修  |  GUARDRAILS</a:t>
+              <a:t>MIGHTYLINK  |  8/26 社内AI研修  |  PROMPT 3 / PUBLISH</a:t>
             </a:r>
           </a:p>
         </p:txBody>
@@ -16396,7 +16298,7 @@
                 <a:ea typeface="Yu Gothic UI"/>
                 <a:cs typeface="Yu Gothic UI"/>
               </a:rPr>
-              <a:t>止める判断も、信頼をつくるデモです</a:t>
+              <a:t>Prompt 3　人が承認してから公開します</a:t>
             </a:r>
           </a:p>
         </p:txBody>
@@ -16655,7 +16557,7 @@
                 <a:ea typeface="Yu Gothic UI"/>
                 <a:cs typeface="Yu Gothic UI"/>
               </a:rPr>
-              <a:t>迷ったら拒否して説明する</a:t>
+              <a:t>公開前に必ず停止</a:t>
             </a:r>
           </a:p>
         </p:txBody>
@@ -16768,7 +16670,7 @@
                 <a:ea typeface="Yu Gothic UI"/>
                 <a:cs typeface="Yu Gothic UI"/>
               </a:rPr>
-              <a:t>公式の優先順位</a:t>
+              <a:t>専用リポジトリだけ</a:t>
             </a:r>
           </a:p>
           <a:p xmlns:a="http://schemas.openxmlformats.org/drawingml/2006/main">
@@ -16795,7 +16697,7 @@
                 <a:ea typeface="Yu Gothic UI"/>
                 <a:cs typeface="Yu Gothic UI"/>
               </a:rPr>
-              <a:t>Deny  &gt;  Ask  &gt;  Allow</a:t>
+              <a:t>main / (root)</a:t>
             </a:r>
           </a:p>
           <a:p xmlns:a="http://schemas.openxmlformats.org/drawingml/2006/main">
@@ -16838,7 +16740,7 @@
                 <a:ea typeface="Yu Gothic UI"/>
                 <a:cs typeface="Yu Gothic UI"/>
               </a:rPr>
-              <a:t>承認する</a:t>
+              <a:t>git status / diff / remote / branch</a:t>
             </a:r>
           </a:p>
           <a:p xmlns:a="http://schemas.openxmlformats.org/drawingml/2006/main">
@@ -16865,7 +16767,7 @@
                 <a:ea typeface="Yu Gothic UI"/>
                 <a:cs typeface="Yu Gothic UI"/>
               </a:rPr>
-              <a:t>・対象がデモ用フォルダ内</a:t>
+              <a:t>secret / PII / 合成マーカー</a:t>
             </a:r>
           </a:p>
           <a:p xmlns:a="http://schemas.openxmlformats.org/drawingml/2006/main">
@@ -16892,7 +16794,7 @@
                 <a:ea typeface="Yu Gothic UI"/>
                 <a:cs typeface="Yu Gothic UI"/>
               </a:rPr>
-              <a:t>・実行内容を説明できる</a:t>
+              <a:t/>
             </a:r>
           </a:p>
           <a:p xmlns:a="http://schemas.openxmlformats.org/drawingml/2006/main">
@@ -16908,7 +16810,7 @@
                 <a:ea typeface="Yu Gothic UI"/>
                 <a:cs typeface="Yu Gothic UI"/>
               </a:rPr>
-              <a:t/>
+              <a:t>「公開してもよいですか？」</a:t>
             </a:r>
           </a:p>
           <a:p xmlns:a="http://schemas.openxmlformats.org/drawingml/2006/main">
@@ -16935,7 +16837,7 @@
                 <a:ea typeface="Yu Gothic UI"/>
                 <a:cs typeface="Yu Gothic UI"/>
               </a:rPr>
-              <a:t>拒否する</a:t>
+              <a:t>正確な「公開して」まで</a:t>
             </a:r>
           </a:p>
           <a:p xmlns:a="http://schemas.openxmlformats.org/drawingml/2006/main">
@@ -16962,34 +16864,7 @@
                 <a:ea typeface="Yu Gothic UI"/>
                 <a:cs typeface="Yu Gothic UI"/>
               </a:rPr>
-              <a:t>・顧客／社員／認証情報を要求</a:t>
-            </a:r>
-          </a:p>
-          <a:p xmlns:a="http://schemas.openxmlformats.org/drawingml/2006/main">
-            <a:pPr algn="l">
-              <a:lnSpc>
-                <a:spcPct val="115000"/>
-              </a:lnSpc>
-              <a:buNone/>
-              <a:defRPr sz="1800" b="0">
-                <a:solidFill>
-                  <a:srgbClr val="14212B"/>
-                </a:solidFill>
-                <a:latin typeface="Yu Gothic UI"/>
-                <a:ea typeface="Yu Gothic UI"/>
-                <a:cs typeface="Yu Gothic UI"/>
-              </a:defRPr>
-            </a:pPr>
-            <a:r>
-              <a:rPr sz="1800" b="0">
-                <a:solidFill>
-                  <a:srgbClr val="14212B"/>
-                </a:solidFill>
-                <a:latin typeface="Yu Gothic UI"/>
-                <a:ea typeface="Yu Gothic UI"/>
-                <a:cs typeface="Yu Gothic UI"/>
-              </a:rPr>
-              <a:t>・外部送信や別フォルダへ書き込む</a:t>
+              <a:t>add / commit / push は禁止</a:t>
             </a:r>
           </a:p>
         </p:txBody>
@@ -17069,7 +16944,7 @@
                 <a:ea typeface="Yu Gothic UI"/>
                 <a:cs typeface="Yu Gothic UI"/>
               </a:rPr>
-              <a:t>REVIEW POLICY</a:t>
+              <a:t>REVIEW POLICY + PUBLISH</a:t>
             </a:r>
           </a:p>
         </p:txBody>
@@ -17083,7 +16958,7 @@
           <p:nvPr/>
         </p:nvPicPr>
         <p:blipFill>
-          <a:blip xmlns:r="http://schemas.openxmlformats.org/officeDocument/2006/relationships" xmlns:a="http://schemas.openxmlformats.org/drawingml/2006/main" r:embed="R7eab600fadf24942"/>
+          <a:blip xmlns:r="http://schemas.openxmlformats.org/officeDocument/2006/relationships" xmlns:a="http://schemas.openxmlformats.org/drawingml/2006/main" r:embed="R6d337d9b18474924"/>
           <a:stretch xmlns:a="http://schemas.openxmlformats.org/drawingml/2006/main">
             <a:fillRect l="0" t="0" r="0" b="0"/>
           </a:stretch>
@@ -17107,7 +16982,7 @@
           <p:nvPr/>
         </p:nvPicPr>
         <p:blipFill>
-          <a:blip xmlns:r="http://schemas.openxmlformats.org/officeDocument/2006/relationships" xmlns:a="http://schemas.openxmlformats.org/drawingml/2006/main" r:embed="R0e765f406d074427"/>
+          <a:blip xmlns:r="http://schemas.openxmlformats.org/officeDocument/2006/relationships" xmlns:a="http://schemas.openxmlformats.org/drawingml/2006/main" r:embed="R966475b2ea1d4fa2"/>
           <a:stretch xmlns:a="http://schemas.openxmlformats.org/drawingml/2006/main"/>
         </p:blipFill>
         <p:spPr>
@@ -17373,7 +17248,7 @@
                 <a:ea typeface="Yu Gothic UI"/>
                 <a:cs typeface="Yu Gothic UI"/>
               </a:rPr>
-              <a:t>MIGHTYLINK  |  8/26 社内AI研修  |  DONE DEFINITION</a:t>
+              <a:t>MIGHTYLINK  |  8/26 社内AI研修  |  PUBLIC PROOF</a:t>
             </a:r>
           </a:p>
         </p:txBody>
@@ -17435,7 +17310,7 @@
                 <a:ea typeface="Yu Gothic UI"/>
                 <a:cs typeface="Yu Gothic UI"/>
               </a:rPr>
-              <a:t>成功判定は3つ。見えたら終わります</a:t>
+              <a:t>成功判定は3つ。公開URLまで見えたら終わります</a:t>
             </a:r>
           </a:p>
         </p:txBody>
@@ -17694,7 +17569,7 @@
                 <a:ea typeface="Yu Gothic UI"/>
                 <a:cs typeface="Yu Gothic UI"/>
               </a:rPr>
-              <a:t>FILE</a:t>
+              <a:t>FILES</a:t>
             </a:r>
           </a:p>
         </p:txBody>
@@ -17862,7 +17737,7 @@
                 <a:ea typeface="Yu Gothic UI"/>
                 <a:cs typeface="Yu Gothic UI"/>
               </a:rPr>
-              <a:t>output/index.html</a:t>
+              <a:t>index.html</a:t>
             </a:r>
           </a:p>
           <a:p xmlns:a="http://schemas.openxmlformats.org/drawingml/2006/main">
@@ -17878,7 +17753,7 @@
                 <a:ea typeface="Yu Gothic UI"/>
                 <a:cs typeface="Yu Gothic UI"/>
               </a:rPr>
-              <a:t/>
+              <a:t>styles.css</a:t>
             </a:r>
           </a:p>
           <a:p xmlns:a="http://schemas.openxmlformats.org/drawingml/2006/main">
@@ -17905,7 +17780,7 @@
                 <a:ea typeface="Yu Gothic UI"/>
                 <a:cs typeface="Yu Gothic UI"/>
               </a:rPr>
-              <a:t>変更ファイルは</a:t>
+              <a:t>app.js</a:t>
             </a:r>
           </a:p>
           <a:p xmlns:a="http://schemas.openxmlformats.org/drawingml/2006/main">
@@ -17932,7 +17807,34 @@
                 <a:ea typeface="Yu Gothic UI"/>
                 <a:cs typeface="Yu Gothic UI"/>
               </a:rPr>
-              <a:t>この1件だけ</a:t>
+              <a:t/>
+            </a:r>
+          </a:p>
+          <a:p xmlns:a="http://schemas.openxmlformats.org/drawingml/2006/main">
+            <a:pPr algn="l">
+              <a:lnSpc>
+                <a:spcPct val="122000"/>
+              </a:lnSpc>
+              <a:buNone/>
+              <a:defRPr sz="2025" b="1">
+                <a:solidFill>
+                  <a:srgbClr val="14212B"/>
+                </a:solidFill>
+                <a:latin typeface="Yu Gothic UI"/>
+                <a:ea typeface="Yu Gothic UI"/>
+                <a:cs typeface="Yu Gothic UI"/>
+              </a:defRPr>
+            </a:pPr>
+            <a:r>
+              <a:rPr sz="2025" b="1">
+                <a:solidFill>
+                  <a:srgbClr val="14212B"/>
+                </a:solidFill>
+                <a:latin typeface="Yu Gothic UI"/>
+                <a:ea typeface="Yu Gothic UI"/>
+                <a:cs typeface="Yu Gothic UI"/>
+              </a:rPr>
+              <a:t>想定外ファイル 0</a:t>
             </a:r>
           </a:p>
         </p:txBody>
@@ -18012,7 +17914,7 @@
                 <a:ea typeface="Yu Gothic UI"/>
                 <a:cs typeface="Yu Gothic UI"/>
               </a:rPr>
-              <a:t>SCREEN</a:t>
+              <a:t>FUNCTION</a:t>
             </a:r>
           </a:p>
         </p:txBody>
@@ -18180,7 +18082,7 @@
                 <a:ea typeface="Yu Gothic UI"/>
                 <a:cs typeface="Yu Gothic UI"/>
               </a:rPr>
-              <a:t>4項目が表示</a:t>
+              <a:t>絞り込み</a:t>
             </a:r>
           </a:p>
           <a:p xmlns:a="http://schemas.openxmlformats.org/drawingml/2006/main">
@@ -18196,7 +18098,7 @@
                 <a:ea typeface="Yu Gothic UI"/>
                 <a:cs typeface="Yu Gothic UI"/>
               </a:rPr>
-              <a:t/>
+              <a:t>4, 1, 1, 1, 1</a:t>
             </a:r>
           </a:p>
           <a:p xmlns:a="http://schemas.openxmlformats.org/drawingml/2006/main">
@@ -18223,7 +18125,7 @@
                 <a:ea typeface="Yu Gothic UI"/>
                 <a:cs typeface="Yu Gothic UI"/>
               </a:rPr>
-              <a:t>文字切れなし</a:t>
+              <a:t/>
             </a:r>
           </a:p>
           <a:p xmlns:a="http://schemas.openxmlformats.org/drawingml/2006/main">
@@ -18250,7 +18152,7 @@
                 <a:ea typeface="Yu Gothic UI"/>
                 <a:cs typeface="Yu Gothic UI"/>
               </a:rPr>
-              <a:t>モバイル幅も確認</a:t>
+              <a:t>参加候補 2件</a:t>
             </a:r>
           </a:p>
         </p:txBody>
@@ -18330,7 +18232,7 @@
                 <a:ea typeface="Yu Gothic UI"/>
                 <a:cs typeface="Yu Gothic UI"/>
               </a:rPr>
-              <a:t>REPORT</a:t>
+              <a:t>PUBLIC</a:t>
             </a:r>
           </a:p>
         </p:txBody>
@@ -18498,7 +18400,7 @@
                 <a:ea typeface="Yu Gothic UI"/>
                 <a:cs typeface="Yu Gothic UI"/>
               </a:rPr>
-              <a:t>変更／確認／未解決</a:t>
+              <a:t>HTTPS 200</a:t>
             </a:r>
           </a:p>
           <a:p xmlns:a="http://schemas.openxmlformats.org/drawingml/2006/main">
@@ -18514,7 +18416,7 @@
                 <a:ea typeface="Yu Gothic UI"/>
                 <a:cs typeface="Yu Gothic UI"/>
               </a:rPr>
-              <a:t/>
+              <a:t>タイトル / 4件</a:t>
             </a:r>
           </a:p>
           <a:p xmlns:a="http://schemas.openxmlformats.org/drawingml/2006/main">
@@ -18541,7 +18443,7 @@
                 <a:ea typeface="Yu Gothic UI"/>
                 <a:cs typeface="Yu Gothic UI"/>
               </a:rPr>
-              <a:t>最後の回答は</a:t>
+              <a:t/>
             </a:r>
           </a:p>
           <a:p xmlns:a="http://schemas.openxmlformats.org/drawingml/2006/main">
@@ -18568,7 +18470,7 @@
                 <a:ea typeface="Yu Gothic UI"/>
                 <a:cs typeface="Yu Gothic UI"/>
               </a:rPr>
-              <a:t>3行で十分</a:t>
+              <a:t>公開URLで確認</a:t>
             </a:r>
           </a:p>
         </p:txBody>

</xml_diff>